<commit_message>
Aggiornato VsCode e Ppoint
</commit_message>
<xml_diff>
--- a/final_project_boolean.pptx
+++ b/final_project_boolean.pptx
@@ -227,7 +227,7 @@
               <a:rPr lang="it-IT" smtClean="0">
                 <a:latin typeface="Tw Cen MT" panose="020B0602020104020603" pitchFamily="34" charset="0"/>
               </a:rPr>
-              <a:t>02/08/2026</a:t>
+              <a:t>06/08/2026</a:t>
             </a:fld>
             <a:endParaRPr lang="it-IT">
               <a:latin typeface="Tw Cen MT" panose="020B0602020104020603" pitchFamily="34" charset="0"/>
@@ -421,7 +421,7 @@
             <a:pPr rtl="0"/>
             <a:fld id="{A8179E5A-E0EC-4D14-85DA-2BF1DBD2D7AB}" type="datetime1">
               <a:rPr lang="it-IT" noProof="0" smtClean="0"/>
-              <a:t>02/08/2026</a:t>
+              <a:t>06/08/2026</a:t>
             </a:fld>
             <a:endParaRPr lang="it-IT" noProof="0"/>
           </a:p>
@@ -31230,8 +31230,8 @@
           </a:p>
         </p:txBody>
       </p:sp>
-      <mc:AlternateContent xmlns:mc="http://schemas.openxmlformats.org/markup-compatibility/2006">
-        <mc:Choice xmlns:a14="http://schemas.microsoft.com/office/drawing/2010/main" Requires="a14">
+      <mc:AlternateContent xmlns:mc="http://schemas.openxmlformats.org/markup-compatibility/2006" xmlns:a14="http://schemas.microsoft.com/office/drawing/2010/main">
+        <mc:Choice Requires="a14">
           <p:sp>
             <p:nvSpPr>
               <p:cNvPr id="13" name="Segnaposto contenuto 12">
@@ -31518,7 +31518,7 @@
             </p:txBody>
           </p:sp>
         </mc:Choice>
-        <mc:Fallback>
+        <mc:Fallback xmlns="">
           <p:sp>
             <p:nvSpPr>
               <p:cNvPr id="13" name="Segnaposto contenuto 12">
@@ -32735,8 +32735,8 @@
           </a:p>
         </p:txBody>
       </p:sp>
-      <mc:AlternateContent xmlns:mc="http://schemas.openxmlformats.org/markup-compatibility/2006">
-        <mc:Choice xmlns:a14="http://schemas.microsoft.com/office/drawing/2010/main" Requires="a14">
+      <mc:AlternateContent xmlns:mc="http://schemas.openxmlformats.org/markup-compatibility/2006" xmlns:a14="http://schemas.microsoft.com/office/drawing/2010/main">
+        <mc:Choice Requires="a14">
           <p:sp>
             <p:nvSpPr>
               <p:cNvPr id="4" name="CasellaDiTesto 3">
@@ -33035,7 +33035,7 @@
                 </a:r>
                 <a:r>
                   <a:rPr lang="it-IT" sz="2000" dirty="0"/>
-                  <a:t>il passaggio da un anno al successivo è associato a una diminuzione media di </a:t>
+                  <a:t>il passaggio da un anno al successivo è associato ad un aumento medio di </a:t>
                 </a:r>
                 <a:r>
                   <a:rPr lang="it-IT" sz="2000" b="1" dirty="0"/>
@@ -33049,7 +33049,7 @@
             </p:txBody>
           </p:sp>
         </mc:Choice>
-        <mc:Fallback>
+        <mc:Fallback xmlns="">
           <p:sp>
             <p:nvSpPr>
               <p:cNvPr id="4" name="CasellaDiTesto 3">
@@ -33522,8 +33522,8 @@
           </a:graphicData>
         </a:graphic>
       </p:graphicFrame>
-      <mc:AlternateContent xmlns:mc="http://schemas.openxmlformats.org/markup-compatibility/2006">
-        <mc:Choice xmlns:a14="http://schemas.microsoft.com/office/drawing/2010/main" Requires="a14">
+      <mc:AlternateContent xmlns:mc="http://schemas.openxmlformats.org/markup-compatibility/2006" xmlns:a14="http://schemas.microsoft.com/office/drawing/2010/main">
+        <mc:Choice Requires="a14">
           <p:sp>
             <p:nvSpPr>
               <p:cNvPr id="2" name="CasellaDiTesto 1">
@@ -33709,7 +33709,7 @@
             </p:txBody>
           </p:sp>
         </mc:Choice>
-        <mc:Fallback>
+        <mc:Fallback xmlns="">
           <p:sp>
             <p:nvSpPr>
               <p:cNvPr id="2" name="CasellaDiTesto 1">
@@ -33754,8 +33754,8 @@
           </p:sp>
         </mc:Fallback>
       </mc:AlternateContent>
-      <mc:AlternateContent xmlns:mc="http://schemas.openxmlformats.org/markup-compatibility/2006">
-        <mc:Choice xmlns:a14="http://schemas.microsoft.com/office/drawing/2010/main" Requires="a14">
+      <mc:AlternateContent xmlns:mc="http://schemas.openxmlformats.org/markup-compatibility/2006" xmlns:a14="http://schemas.microsoft.com/office/drawing/2010/main">
+        <mc:Choice Requires="a14">
           <p:sp>
             <p:nvSpPr>
               <p:cNvPr id="7" name="CasellaDiTesto 6">
@@ -33803,7 +33803,7 @@
             </p:txBody>
           </p:sp>
         </mc:Choice>
-        <mc:Fallback>
+        <mc:Fallback xmlns="">
           <p:sp>
             <p:nvSpPr>
               <p:cNvPr id="7" name="CasellaDiTesto 6">
@@ -34044,10 +34044,10 @@
       </p:pic>
       <p:pic>
         <p:nvPicPr>
-          <p:cNvPr id="8" name="Immagine 7">
-            <a:extLst>
-              <a:ext uri="{FF2B5EF4-FFF2-40B4-BE49-F238E27FC236}">
-                <a16:creationId xmlns:a16="http://schemas.microsoft.com/office/drawing/2014/main" id="{674BA60E-0A20-00C3-DE28-023D54D4FC66}"/>
+          <p:cNvPr id="13" name="Immagine 12" descr="Immagine che contiene testo, Carattere, numero, linea&#10;&#10;Il contenuto generato dall'IA potrebbe non essere corretto.">
+            <a:extLst>
+              <a:ext uri="{FF2B5EF4-FFF2-40B4-BE49-F238E27FC236}">
+                <a16:creationId xmlns:a16="http://schemas.microsoft.com/office/drawing/2014/main" id="{E057E5B1-C9F0-CAA2-86A6-8F41FFAE9167}"/>
               </a:ext>
             </a:extLst>
           </p:cNvPr>
@@ -34064,8 +34064,8 @@
         </p:blipFill>
         <p:spPr>
           <a:xfrm>
-            <a:off x="548641" y="3426974"/>
-            <a:ext cx="11380007" cy="1656184"/>
+            <a:off x="548640" y="5373216"/>
+            <a:ext cx="11380007" cy="1168460"/>
           </a:xfrm>
           <a:prstGeom prst="rect">
             <a:avLst/>
@@ -34074,10 +34074,10 @@
       </p:pic>
       <p:pic>
         <p:nvPicPr>
-          <p:cNvPr id="13" name="Immagine 12" descr="Immagine che contiene testo, Carattere, numero, linea&#10;&#10;Il contenuto generato dall'IA potrebbe non essere corretto.">
-            <a:extLst>
-              <a:ext uri="{FF2B5EF4-FFF2-40B4-BE49-F238E27FC236}">
-                <a16:creationId xmlns:a16="http://schemas.microsoft.com/office/drawing/2014/main" id="{E057E5B1-C9F0-CAA2-86A6-8F41FFAE9167}"/>
+          <p:cNvPr id="16" name="Immagine 15" descr="Immagine che contiene testo, numero, Carattere, linea&#10;&#10;Il contenuto generato dall'IA potrebbe non essere corretto.">
+            <a:extLst>
+              <a:ext uri="{FF2B5EF4-FFF2-40B4-BE49-F238E27FC236}">
+                <a16:creationId xmlns:a16="http://schemas.microsoft.com/office/drawing/2014/main" id="{70157FA6-920E-4F46-FAAA-1512EA27C1D3}"/>
               </a:ext>
             </a:extLst>
           </p:cNvPr>
@@ -34088,36 +34088,6 @@
         </p:nvPicPr>
         <p:blipFill>
           <a:blip r:embed="rId5"/>
-          <a:stretch>
-            <a:fillRect/>
-          </a:stretch>
-        </p:blipFill>
-        <p:spPr>
-          <a:xfrm>
-            <a:off x="548640" y="5373216"/>
-            <a:ext cx="11380007" cy="1168460"/>
-          </a:xfrm>
-          <a:prstGeom prst="rect">
-            <a:avLst/>
-          </a:prstGeom>
-        </p:spPr>
-      </p:pic>
-      <p:pic>
-        <p:nvPicPr>
-          <p:cNvPr id="16" name="Immagine 15" descr="Immagine che contiene testo, numero, Carattere, linea&#10;&#10;Il contenuto generato dall'IA potrebbe non essere corretto.">
-            <a:extLst>
-              <a:ext uri="{FF2B5EF4-FFF2-40B4-BE49-F238E27FC236}">
-                <a16:creationId xmlns:a16="http://schemas.microsoft.com/office/drawing/2014/main" id="{70157FA6-920E-4F46-FAAA-1512EA27C1D3}"/>
-              </a:ext>
-            </a:extLst>
-          </p:cNvPr>
-          <p:cNvPicPr>
-            <a:picLocks noChangeAspect="1"/>
-          </p:cNvPicPr>
-          <p:nvPr/>
-        </p:nvPicPr>
-        <p:blipFill>
-          <a:blip r:embed="rId6"/>
           <a:stretch>
             <a:fillRect/>
           </a:stretch>
@@ -34184,10 +34154,10 @@
       </p:sp>
       <p:sp>
         <p:nvSpPr>
-          <p:cNvPr id="5" name="Rettangolo 4">
-            <a:extLst>
-              <a:ext uri="{FF2B5EF4-FFF2-40B4-BE49-F238E27FC236}">
-                <a16:creationId xmlns:a16="http://schemas.microsoft.com/office/drawing/2014/main" id="{A419D4CF-B068-2E55-57FC-02FBA65FB728}"/>
+          <p:cNvPr id="6" name="Rettangolo 5">
+            <a:extLst>
+              <a:ext uri="{FF2B5EF4-FFF2-40B4-BE49-F238E27FC236}">
+                <a16:creationId xmlns:a16="http://schemas.microsoft.com/office/drawing/2014/main" id="{4FD322E6-55B4-CE83-AF2B-28A98EC7DA08}"/>
               </a:ext>
             </a:extLst>
           </p:cNvPr>
@@ -34196,8 +34166,8 @@
         </p:nvSpPr>
         <p:spPr>
           <a:xfrm>
-            <a:off x="5994628" y="3407232"/>
-            <a:ext cx="1109484" cy="1656184"/>
+            <a:off x="6348028" y="5373216"/>
+            <a:ext cx="3564396" cy="1168460"/>
           </a:xfrm>
           <a:prstGeom prst="rect">
             <a:avLst/>
@@ -34232,12 +34202,42 @@
           </a:p>
         </p:txBody>
       </p:sp>
-      <p:sp>
-        <p:nvSpPr>
-          <p:cNvPr id="6" name="Rettangolo 5">
-            <a:extLst>
-              <a:ext uri="{FF2B5EF4-FFF2-40B4-BE49-F238E27FC236}">
-                <a16:creationId xmlns:a16="http://schemas.microsoft.com/office/drawing/2014/main" id="{4FD322E6-55B4-CE83-AF2B-28A98EC7DA08}"/>
+      <p:pic>
+        <p:nvPicPr>
+          <p:cNvPr id="3" name="Immagine 2" descr="Immagine che contiene testo, numero, Carattere, linea&#10;&#10;Il contenuto generato dall'IA potrebbe non essere corretto.">
+            <a:extLst>
+              <a:ext uri="{FF2B5EF4-FFF2-40B4-BE49-F238E27FC236}">
+                <a16:creationId xmlns:a16="http://schemas.microsoft.com/office/drawing/2014/main" id="{4B6EB369-9E3A-5545-0319-1955FDE9C5CB}"/>
+              </a:ext>
+            </a:extLst>
+          </p:cNvPr>
+          <p:cNvPicPr>
+            <a:picLocks noChangeAspect="1"/>
+          </p:cNvPicPr>
+          <p:nvPr/>
+        </p:nvPicPr>
+        <p:blipFill>
+          <a:blip r:embed="rId6"/>
+          <a:stretch>
+            <a:fillRect/>
+          </a:stretch>
+        </p:blipFill>
+        <p:spPr>
+          <a:xfrm>
+            <a:off x="548640" y="3342913"/>
+            <a:ext cx="11380006" cy="1803493"/>
+          </a:xfrm>
+          <a:prstGeom prst="rect">
+            <a:avLst/>
+          </a:prstGeom>
+        </p:spPr>
+      </p:pic>
+      <p:sp>
+        <p:nvSpPr>
+          <p:cNvPr id="7" name="Rettangolo 6">
+            <a:extLst>
+              <a:ext uri="{FF2B5EF4-FFF2-40B4-BE49-F238E27FC236}">
+                <a16:creationId xmlns:a16="http://schemas.microsoft.com/office/drawing/2014/main" id="{48AA1238-4051-0034-56B4-54D15118C80B}"/>
               </a:ext>
             </a:extLst>
           </p:cNvPr>
@@ -34246,8 +34246,8 @@
         </p:nvSpPr>
         <p:spPr>
           <a:xfrm>
-            <a:off x="6348028" y="5373216"/>
-            <a:ext cx="3564396" cy="1168460"/>
+            <a:off x="6129996" y="3342913"/>
+            <a:ext cx="1008112" cy="1803492"/>
           </a:xfrm>
           <a:prstGeom prst="rect">
             <a:avLst/>
@@ -34689,8 +34689,8 @@
           </a:xfrm>
         </p:spPr>
       </p:pic>
-      <mc:AlternateContent xmlns:mc="http://schemas.openxmlformats.org/markup-compatibility/2006">
-        <mc:Choice xmlns:a14="http://schemas.microsoft.com/office/drawing/2010/main" Requires="a14">
+      <mc:AlternateContent xmlns:mc="http://schemas.openxmlformats.org/markup-compatibility/2006" xmlns:a14="http://schemas.microsoft.com/office/drawing/2010/main">
+        <mc:Choice Requires="a14">
           <p:sp>
             <p:nvSpPr>
               <p:cNvPr id="2" name="Segnaposto contenuto 12">
@@ -35091,7 +35091,7 @@
             </p:txBody>
           </p:sp>
         </mc:Choice>
-        <mc:Fallback>
+        <mc:Fallback xmlns="">
           <p:sp>
             <p:nvSpPr>
               <p:cNvPr id="2" name="Segnaposto contenuto 12">

</xml_diff>